<commit_message>
cambio diagrama de componentes
se cambia diagrama de componente en rama de incremento1 en el word y se agrega en la ppt de presentación
</commit_message>
<xml_diff>
--- a/INCREMENTO1/PPTS/PPt Primer incremento scrum++(2).pptx
+++ b/INCREMENTO1/PPTS/PPt Primer incremento scrum++(2).pptx
@@ -5,7 +5,7 @@
     <p:sldMasterId id="2147483695" r:id="rId1"/>
   </p:sldMasterIdLst>
   <p:notesMasterIdLst>
-    <p:notesMasterId r:id="rId14"/>
+    <p:notesMasterId r:id="rId15"/>
   </p:notesMasterIdLst>
   <p:sldIdLst>
     <p:sldId id="256" r:id="rId2"/>
@@ -16,10 +16,11 @@
     <p:sldId id="260" r:id="rId7"/>
     <p:sldId id="261" r:id="rId8"/>
     <p:sldId id="270" r:id="rId9"/>
-    <p:sldId id="269" r:id="rId10"/>
-    <p:sldId id="268" r:id="rId11"/>
-    <p:sldId id="265" r:id="rId12"/>
-    <p:sldId id="266" r:id="rId13"/>
+    <p:sldId id="271" r:id="rId10"/>
+    <p:sldId id="269" r:id="rId11"/>
+    <p:sldId id="268" r:id="rId12"/>
+    <p:sldId id="265" r:id="rId13"/>
+    <p:sldId id="266" r:id="rId14"/>
   </p:sldIdLst>
   <p:sldSz cx="9144000" cy="6858000" type="screen4x3"/>
   <p:notesSz cx="6858000" cy="9144000"/>
@@ -219,7 +220,7 @@
           <a:p>
             <a:fld id="{56824AA8-F311-4ABC-8748-4A852C5A6ECD}" type="datetimeFigureOut">
               <a:rPr lang="es-419" smtClean="0"/>
-              <a:t>23/6/2025</a:t>
+              <a:t>18/8/2025</a:t>
             </a:fld>
             <a:endParaRPr lang="es-419"/>
           </a:p>
@@ -1365,7 +1366,7 @@
           <a:p>
             <a:fld id="{5BCAD085-E8A6-8845-BD4E-CB4CCA059FC4}" type="datetimeFigureOut">
               <a:rPr lang="en-US" smtClean="0"/>
-              <a:t>6/23/2025</a:t>
+              <a:t>8/18/2025</a:t>
             </a:fld>
             <a:endParaRPr lang="en-US"/>
           </a:p>
@@ -1616,7 +1617,7 @@
           <a:p>
             <a:fld id="{5BCAD085-E8A6-8845-BD4E-CB4CCA059FC4}" type="datetimeFigureOut">
               <a:rPr lang="en-US" smtClean="0"/>
-              <a:t>6/23/2025</a:t>
+              <a:t>8/18/2025</a:t>
             </a:fld>
             <a:endParaRPr lang="en-US"/>
           </a:p>
@@ -1930,7 +1931,7 @@
           <a:p>
             <a:fld id="{5BCAD085-E8A6-8845-BD4E-CB4CCA059FC4}" type="datetimeFigureOut">
               <a:rPr lang="en-US" smtClean="0"/>
-              <a:t>6/23/2025</a:t>
+              <a:t>8/18/2025</a:t>
             </a:fld>
             <a:endParaRPr lang="en-US"/>
           </a:p>
@@ -2263,7 +2264,7 @@
           <a:p>
             <a:fld id="{5BCAD085-E8A6-8845-BD4E-CB4CCA059FC4}" type="datetimeFigureOut">
               <a:rPr lang="en-US" smtClean="0"/>
-              <a:t>6/23/2025</a:t>
+              <a:t>8/18/2025</a:t>
             </a:fld>
             <a:endParaRPr lang="en-US"/>
           </a:p>
@@ -2577,7 +2578,7 @@
           <a:p>
             <a:fld id="{5BCAD085-E8A6-8845-BD4E-CB4CCA059FC4}" type="datetimeFigureOut">
               <a:rPr lang="en-US" smtClean="0"/>
-              <a:t>6/23/2025</a:t>
+              <a:t>8/18/2025</a:t>
             </a:fld>
             <a:endParaRPr lang="en-US"/>
           </a:p>
@@ -2970,7 +2971,7 @@
           <a:p>
             <a:fld id="{5BCAD085-E8A6-8845-BD4E-CB4CCA059FC4}" type="datetimeFigureOut">
               <a:rPr lang="en-US" smtClean="0"/>
-              <a:t>6/23/2025</a:t>
+              <a:t>8/18/2025</a:t>
             </a:fld>
             <a:endParaRPr lang="en-US"/>
           </a:p>
@@ -3140,7 +3141,7 @@
           <a:p>
             <a:fld id="{5BCAD085-E8A6-8845-BD4E-CB4CCA059FC4}" type="datetimeFigureOut">
               <a:rPr lang="en-US" smtClean="0"/>
-              <a:t>6/23/2025</a:t>
+              <a:t>8/18/2025</a:t>
             </a:fld>
             <a:endParaRPr lang="en-US"/>
           </a:p>
@@ -3320,7 +3321,7 @@
           <a:p>
             <a:fld id="{5BCAD085-E8A6-8845-BD4E-CB4CCA059FC4}" type="datetimeFigureOut">
               <a:rPr lang="en-US" smtClean="0"/>
-              <a:t>6/23/2025</a:t>
+              <a:t>8/18/2025</a:t>
             </a:fld>
             <a:endParaRPr lang="en-US"/>
           </a:p>
@@ -3490,7 +3491,7 @@
           <a:p>
             <a:fld id="{5BCAD085-E8A6-8845-BD4E-CB4CCA059FC4}" type="datetimeFigureOut">
               <a:rPr lang="en-US" smtClean="0"/>
-              <a:t>6/23/2025</a:t>
+              <a:t>8/18/2025</a:t>
             </a:fld>
             <a:endParaRPr lang="en-US"/>
           </a:p>
@@ -3737,7 +3738,7 @@
           <a:p>
             <a:fld id="{5BCAD085-E8A6-8845-BD4E-CB4CCA059FC4}" type="datetimeFigureOut">
               <a:rPr lang="en-US" smtClean="0"/>
-              <a:t>6/23/2025</a:t>
+              <a:t>8/18/2025</a:t>
             </a:fld>
             <a:endParaRPr lang="en-US"/>
           </a:p>
@@ -4034,7 +4035,7 @@
           <a:p>
             <a:fld id="{5BCAD085-E8A6-8845-BD4E-CB4CCA059FC4}" type="datetimeFigureOut">
               <a:rPr lang="en-US" smtClean="0"/>
-              <a:t>6/23/2025</a:t>
+              <a:t>8/18/2025</a:t>
             </a:fld>
             <a:endParaRPr lang="en-US"/>
           </a:p>
@@ -4413,7 +4414,7 @@
           <a:p>
             <a:fld id="{5BCAD085-E8A6-8845-BD4E-CB4CCA059FC4}" type="datetimeFigureOut">
               <a:rPr lang="en-US" smtClean="0"/>
-              <a:t>6/23/2025</a:t>
+              <a:t>8/18/2025</a:t>
             </a:fld>
             <a:endParaRPr lang="en-US"/>
           </a:p>
@@ -4536,7 +4537,7 @@
           <a:p>
             <a:fld id="{5BCAD085-E8A6-8845-BD4E-CB4CCA059FC4}" type="datetimeFigureOut">
               <a:rPr lang="en-US" smtClean="0"/>
-              <a:t>6/23/2025</a:t>
+              <a:t>8/18/2025</a:t>
             </a:fld>
             <a:endParaRPr lang="en-US"/>
           </a:p>
@@ -4631,7 +4632,7 @@
           <a:p>
             <a:fld id="{5BCAD085-E8A6-8845-BD4E-CB4CCA059FC4}" type="datetimeFigureOut">
               <a:rPr lang="en-US" smtClean="0"/>
-              <a:t>6/23/2025</a:t>
+              <a:t>8/18/2025</a:t>
             </a:fld>
             <a:endParaRPr lang="en-US"/>
           </a:p>
@@ -4886,7 +4887,7 @@
           <a:p>
             <a:fld id="{5BCAD085-E8A6-8845-BD4E-CB4CCA059FC4}" type="datetimeFigureOut">
               <a:rPr lang="en-US" smtClean="0"/>
-              <a:t>6/23/2025</a:t>
+              <a:t>8/18/2025</a:t>
             </a:fld>
             <a:endParaRPr lang="en-US"/>
           </a:p>
@@ -5149,7 +5150,7 @@
           <a:p>
             <a:fld id="{5BCAD085-E8A6-8845-BD4E-CB4CCA059FC4}" type="datetimeFigureOut">
               <a:rPr lang="en-US" smtClean="0"/>
-              <a:t>6/23/2025</a:t>
+              <a:t>8/18/2025</a:t>
             </a:fld>
             <a:endParaRPr lang="en-US"/>
           </a:p>
@@ -5963,7 +5964,7 @@
           <a:p>
             <a:fld id="{5BCAD085-E8A6-8845-BD4E-CB4CCA059FC4}" type="datetimeFigureOut">
               <a:rPr lang="en-US" smtClean="0"/>
-              <a:t>6/23/2025</a:t>
+              <a:t>8/18/2025</a:t>
             </a:fld>
             <a:endParaRPr lang="en-US"/>
           </a:p>
@@ -6875,6 +6876,144 @@
           <p:cNvPr id="2" name="Título 1">
             <a:extLst>
               <a:ext uri="{FF2B5EF4-FFF2-40B4-BE49-F238E27FC236}">
+                <a16:creationId xmlns:a16="http://schemas.microsoft.com/office/drawing/2014/main" id="{51D04868-6B6C-BC5F-4E76-EB6B6528B22E}"/>
+              </a:ext>
+            </a:extLst>
+          </p:cNvPr>
+          <p:cNvSpPr>
+            <a:spLocks noGrp="1"/>
+          </p:cNvSpPr>
+          <p:nvPr>
+            <p:ph type="title"/>
+          </p:nvPr>
+        </p:nvSpPr>
+        <p:spPr/>
+        <p:txBody>
+          <a:bodyPr/>
+          <a:lstStyle/>
+          <a:p>
+            <a:r>
+              <a:rPr lang="en-US" dirty="0"/>
+              <a:t>Vista Externa: Caso de Uso</a:t>
+            </a:r>
+            <a:endParaRPr lang="es-419" dirty="0"/>
+          </a:p>
+        </p:txBody>
+      </p:sp>
+      <p:pic>
+        <p:nvPicPr>
+          <p:cNvPr id="2050" name="Picture 2" descr="Interfaz de usuario gráfica, Texto&#10;&#10;El contenido generado por IA puede ser incorrecto., Imagen">
+            <a:extLst>
+              <a:ext uri="{FF2B5EF4-FFF2-40B4-BE49-F238E27FC236}">
+                <a16:creationId xmlns:a16="http://schemas.microsoft.com/office/drawing/2014/main" id="{05EE198D-28BE-CDE3-15EA-95DCED101161}"/>
+              </a:ext>
+            </a:extLst>
+          </p:cNvPr>
+          <p:cNvPicPr>
+            <a:picLocks noGrp="1" noChangeAspect="1" noChangeArrowheads="1"/>
+          </p:cNvPicPr>
+          <p:nvPr>
+            <p:ph idx="1"/>
+          </p:nvPr>
+        </p:nvPicPr>
+        <p:blipFill>
+          <a:blip r:embed="rId2">
+            <a:extLst>
+              <a:ext uri="{28A0092B-C50C-407E-A947-70E740481C1C}">
+                <a14:useLocalDpi xmlns:a14="http://schemas.microsoft.com/office/drawing/2010/main" val="0"/>
+              </a:ext>
+            </a:extLst>
+          </a:blip>
+          <a:srcRect/>
+          <a:stretch>
+            <a:fillRect/>
+          </a:stretch>
+        </p:blipFill>
+        <p:spPr bwMode="auto">
+          <a:xfrm>
+            <a:off x="1035075" y="1513246"/>
+            <a:ext cx="5377487" cy="4735154"/>
+          </a:xfrm>
+          <a:prstGeom prst="rect">
+            <a:avLst/>
+          </a:prstGeom>
+          <a:noFill/>
+          <a:extLst>
+            <a:ext uri="{909E8E84-426E-40DD-AFC4-6F175D3DCCD1}">
+              <a14:hiddenFill xmlns:a14="http://schemas.microsoft.com/office/drawing/2010/main">
+                <a:solidFill>
+                  <a:srgbClr val="FFFFFF"/>
+                </a:solidFill>
+              </a14:hiddenFill>
+            </a:ext>
+          </a:extLst>
+        </p:spPr>
+      </p:pic>
+      <p:pic>
+        <p:nvPicPr>
+          <p:cNvPr id="3" name="Imagen 2" descr="Icono&#10;&#10;El contenido generado por IA puede ser incorrecto.">
+            <a:extLst>
+              <a:ext uri="{FF2B5EF4-FFF2-40B4-BE49-F238E27FC236}">
+                <a16:creationId xmlns:a16="http://schemas.microsoft.com/office/drawing/2014/main" id="{509AC30C-D0A8-D9E2-7C1A-929CC29B8862}"/>
+              </a:ext>
+            </a:extLst>
+          </p:cNvPr>
+          <p:cNvPicPr>
+            <a:picLocks noChangeAspect="1"/>
+          </p:cNvPicPr>
+          <p:nvPr/>
+        </p:nvPicPr>
+        <p:blipFill>
+          <a:blip r:embed="rId3"/>
+          <a:stretch>
+            <a:fillRect/>
+          </a:stretch>
+        </p:blipFill>
+        <p:spPr>
+          <a:xfrm>
+            <a:off x="7764292" y="108352"/>
+            <a:ext cx="1137067" cy="956207"/>
+          </a:xfrm>
+          <a:prstGeom prst="rect">
+            <a:avLst/>
+          </a:prstGeom>
+        </p:spPr>
+      </p:pic>
+    </p:spTree>
+    <p:extLst>
+      <p:ext uri="{BB962C8B-B14F-4D97-AF65-F5344CB8AC3E}">
+        <p14:creationId xmlns:p14="http://schemas.microsoft.com/office/powerpoint/2010/main" val="2414588374"/>
+      </p:ext>
+    </p:extLst>
+  </p:cSld>
+  <p:clrMapOvr>
+    <a:masterClrMapping/>
+  </p:clrMapOvr>
+</p:sld>
+</file>
+
+<file path=ppt/slides/slide11.xml><?xml version="1.0" encoding="utf-8"?>
+<p:sld xmlns:a="http://schemas.openxmlformats.org/drawingml/2006/main" xmlns:r="http://schemas.openxmlformats.org/officeDocument/2006/relationships" xmlns:p="http://schemas.openxmlformats.org/presentationml/2006/main">
+  <p:cSld>
+    <p:spTree>
+      <p:nvGrpSpPr>
+        <p:cNvPr id="1" name=""/>
+        <p:cNvGrpSpPr/>
+        <p:nvPr/>
+      </p:nvGrpSpPr>
+      <p:grpSpPr>
+        <a:xfrm>
+          <a:off x="0" y="0"/>
+          <a:ext cx="0" cy="0"/>
+          <a:chOff x="0" y="0"/>
+          <a:chExt cx="0" cy="0"/>
+        </a:xfrm>
+      </p:grpSpPr>
+      <p:sp>
+        <p:nvSpPr>
+          <p:cNvPr id="2" name="Título 1">
+            <a:extLst>
+              <a:ext uri="{FF2B5EF4-FFF2-40B4-BE49-F238E27FC236}">
                 <a16:creationId xmlns:a16="http://schemas.microsoft.com/office/drawing/2014/main" id="{F3954F04-618E-965B-2846-4882C9D27CE3}"/>
               </a:ext>
             </a:extLst>
@@ -7004,7 +7143,7 @@
 </p:sld>
 </file>
 
-<file path=ppt/slides/slide11.xml><?xml version="1.0" encoding="utf-8"?>
+<file path=ppt/slides/slide12.xml><?xml version="1.0" encoding="utf-8"?>
 <p:sld xmlns:a="http://schemas.openxmlformats.org/drawingml/2006/main" xmlns:r="http://schemas.openxmlformats.org/officeDocument/2006/relationships" xmlns:p="http://schemas.openxmlformats.org/presentationml/2006/main">
   <p:cSld>
     <p:spTree>
@@ -7175,7 +7314,7 @@
 </p:sld>
 </file>
 
-<file path=ppt/slides/slide12.xml><?xml version="1.0" encoding="utf-8"?>
+<file path=ppt/slides/slide13.xml><?xml version="1.0" encoding="utf-8"?>
 <p:sld xmlns:a="http://schemas.openxmlformats.org/drawingml/2006/main" xmlns:r="http://schemas.openxmlformats.org/officeDocument/2006/relationships" xmlns:p="http://schemas.openxmlformats.org/presentationml/2006/main">
   <p:cSld>
     <p:spTree>
@@ -10453,7 +10592,7 @@
           <p:cNvPr id="2" name="Título 1">
             <a:extLst>
               <a:ext uri="{FF2B5EF4-FFF2-40B4-BE49-F238E27FC236}">
-                <a16:creationId xmlns:a16="http://schemas.microsoft.com/office/drawing/2014/main" id="{51D04868-6B6C-BC5F-4E76-EB6B6528B22E}"/>
+                <a16:creationId xmlns:a16="http://schemas.microsoft.com/office/drawing/2014/main" id="{0213BF8A-1C44-4905-5A4B-ED78D0261F28}"/>
               </a:ext>
             </a:extLst>
           </p:cNvPr>
@@ -10470,68 +10609,18 @@
           <a:lstStyle/>
           <a:p>
             <a:r>
-              <a:rPr lang="en-US" dirty="0"/>
-              <a:t>Vista Externa: Caso de Uso</a:t>
-            </a:r>
-            <a:endParaRPr lang="es-419" dirty="0"/>
+              <a:rPr lang="es-CL" dirty="0"/>
+              <a:t>DIAGRAMA DE COMPONENTES</a:t>
+            </a:r>
           </a:p>
         </p:txBody>
       </p:sp>
       <p:pic>
         <p:nvPicPr>
-          <p:cNvPr id="2050" name="Picture 2" descr="Interfaz de usuario gráfica, Texto&#10;&#10;El contenido generado por IA puede ser incorrecto., Imagen">
+          <p:cNvPr id="4" name="Imagen 3" descr="Diagrama&#10;&#10;El contenido generado por IA puede ser incorrecto.">
             <a:extLst>
               <a:ext uri="{FF2B5EF4-FFF2-40B4-BE49-F238E27FC236}">
-                <a16:creationId xmlns:a16="http://schemas.microsoft.com/office/drawing/2014/main" id="{05EE198D-28BE-CDE3-15EA-95DCED101161}"/>
-              </a:ext>
-            </a:extLst>
-          </p:cNvPr>
-          <p:cNvPicPr>
-            <a:picLocks noGrp="1" noChangeAspect="1" noChangeArrowheads="1"/>
-          </p:cNvPicPr>
-          <p:nvPr>
-            <p:ph idx="1"/>
-          </p:nvPr>
-        </p:nvPicPr>
-        <p:blipFill>
-          <a:blip r:embed="rId2">
-            <a:extLst>
-              <a:ext uri="{28A0092B-C50C-407E-A947-70E740481C1C}">
-                <a14:useLocalDpi xmlns:a14="http://schemas.microsoft.com/office/drawing/2010/main" val="0"/>
-              </a:ext>
-            </a:extLst>
-          </a:blip>
-          <a:srcRect/>
-          <a:stretch>
-            <a:fillRect/>
-          </a:stretch>
-        </p:blipFill>
-        <p:spPr bwMode="auto">
-          <a:xfrm>
-            <a:off x="1035075" y="1513246"/>
-            <a:ext cx="5377487" cy="4735154"/>
-          </a:xfrm>
-          <a:prstGeom prst="rect">
-            <a:avLst/>
-          </a:prstGeom>
-          <a:noFill/>
-          <a:extLst>
-            <a:ext uri="{909E8E84-426E-40DD-AFC4-6F175D3DCCD1}">
-              <a14:hiddenFill xmlns:a14="http://schemas.microsoft.com/office/drawing/2010/main">
-                <a:solidFill>
-                  <a:srgbClr val="FFFFFF"/>
-                </a:solidFill>
-              </a14:hiddenFill>
-            </a:ext>
-          </a:extLst>
-        </p:spPr>
-      </p:pic>
-      <p:pic>
-        <p:nvPicPr>
-          <p:cNvPr id="3" name="Imagen 2" descr="Icono&#10;&#10;El contenido generado por IA puede ser incorrecto.">
-            <a:extLst>
-              <a:ext uri="{FF2B5EF4-FFF2-40B4-BE49-F238E27FC236}">
-                <a16:creationId xmlns:a16="http://schemas.microsoft.com/office/drawing/2014/main" id="{509AC30C-D0A8-D9E2-7C1A-929CC29B8862}"/>
+                <a16:creationId xmlns:a16="http://schemas.microsoft.com/office/drawing/2014/main" id="{14F267B6-D12B-6CB6-9B7E-D3A4BEC07ADC}"/>
               </a:ext>
             </a:extLst>
           </p:cNvPr>
@@ -10541,15 +10630,21 @@
           <p:nvPr/>
         </p:nvPicPr>
         <p:blipFill>
-          <a:blip r:embed="rId3"/>
+          <a:blip r:embed="rId2" cstate="print">
+            <a:extLst>
+              <a:ext uri="{28A0092B-C50C-407E-A947-70E740481C1C}">
+                <a14:useLocalDpi xmlns:a14="http://schemas.microsoft.com/office/drawing/2010/main" val="0"/>
+              </a:ext>
+            </a:extLst>
+          </a:blip>
           <a:stretch>
             <a:fillRect/>
           </a:stretch>
         </p:blipFill>
         <p:spPr>
           <a:xfrm>
-            <a:off x="7764292" y="108352"/>
-            <a:ext cx="1137067" cy="956207"/>
+            <a:off x="477621" y="1807899"/>
+            <a:ext cx="8355933" cy="3119702"/>
           </a:xfrm>
           <a:prstGeom prst="rect">
             <a:avLst/>
@@ -10559,7 +10654,7 @@
     </p:spTree>
     <p:extLst>
       <p:ext uri="{BB962C8B-B14F-4D97-AF65-F5344CB8AC3E}">
-        <p14:creationId xmlns:p14="http://schemas.microsoft.com/office/powerpoint/2010/main" val="2414588374"/>
+        <p14:creationId xmlns:p14="http://schemas.microsoft.com/office/powerpoint/2010/main" val="1104023212"/>
       </p:ext>
     </p:extLst>
   </p:cSld>

</xml_diff>